<commit_message>
Update report and slides to corrected survey/heartbeat numbers
- Local-time (Europe/Helsinki) heartbeat coverage: 33.4% mean, 37 participants;
  add Oct 13-16 coverage figure (39 participants, 37.6%)
- Survey counts after offboarding split and duplicate removal (711/561/150)
- One response per participant: onboarding 38, WHO-5 37, BFI-10 42; updated
  demographics, WHO-5 and BFI-10 statistics, stress/sleep counts
- Processed-file tables: new row counts, cognition parquet files
- Slides: same numbers, regenerated figures
- Add reports/images/dtu.png so the report compiles from a clean checkout
</commit_message>
<xml_diff>
--- a/reports/ubilife_presentation.pptx
+++ b/reports/ubilife_presentation.pptx
@@ -6371,7 +6371,7 @@
                 </a:solidFill>
                 <a:latin typeface="Calibri"/>
               </a:rPr>
-              <a:t>765 survey triggers, 614 submitted (80.3% completion)</a:t>
+              <a:t>711 survey triggers, 561 submitted (78.9% completion)</a:t>
             </a:r>
             <a:endParaRPr b="0" lang="en-US" sz="1800" spc="-1" strike="noStrike">
               <a:solidFill>
@@ -6405,7 +6405,7 @@
                 </a:solidFill>
                 <a:latin typeface="Calibri"/>
               </a:rPr>
-              <a:t>Submissions peaked Oct 13–16</a:t>
+              <a:t>Submissions peaked Oct 14–16</a:t>
             </a:r>
             <a:endParaRPr b="0" lang="en-US" sz="1800" spc="-1" strike="noStrike">
               <a:solidFill>
@@ -6656,7 +6656,7 @@
                 </a:solidFill>
                 <a:latin typeface="Calibri"/>
               </a:rPr>
-              <a:t>40 participants with valid age data (median 30, range 23–58)</a:t>
+              <a:t>38 participants with valid age data (median 30, range 23–58)</a:t>
             </a:r>
             <a:endParaRPr b="0" lang="en-US" sz="1800" spc="-1" strike="noStrike">
               <a:solidFill>
@@ -6690,7 +6690,7 @@
                 </a:solidFill>
                 <a:latin typeface="Calibri"/>
               </a:rPr>
-              <a:t>Gender: 60% male, 40% female</a:t>
+              <a:t>Gender: 58% male, 42% female</a:t>
             </a:r>
             <a:endParaRPr b="0" lang="en-US" sz="1800" spc="-1" strike="noStrike">
               <a:solidFill>
@@ -6724,7 +6724,7 @@
                 </a:solidFill>
                 <a:latin typeface="Calibri"/>
               </a:rPr>
-              <a:t>Roles: 55% students, 25% professors, 15% postdocs, 5% researchers</a:t>
+              <a:t>Roles: 58% students, 21% professors, 16% postdocs, 5% researchers</a:t>
             </a:r>
             <a:endParaRPr b="0" lang="en-US" sz="1800" spc="-1" strike="noStrike">
               <a:solidFill>
@@ -6758,7 +6758,7 @@
                 </a:solidFill>
                 <a:latin typeface="Calibri"/>
               </a:rPr>
-              <a:t>55% attending UbiComp for the first time</a:t>
+              <a:t>58% attending UbiComp for the first time</a:t>
             </a:r>
             <a:endParaRPr b="0" lang="en-US" sz="1800" spc="-1" strike="noStrike">
               <a:solidFill>
@@ -6792,7 +6792,7 @@
                 </a:solidFill>
                 <a:latin typeface="Calibri"/>
               </a:rPr>
-              <a:t>22.5% had attended 4–6 previous editions</a:t>
+              <a:t>23.7% had attended 4–6 previous editions</a:t>
             </a:r>
             <a:endParaRPr b="0" lang="en-US" sz="1800" spc="-1" strike="noStrike">
               <a:solidFill>
@@ -7054,7 +7054,7 @@
                 </a:solidFill>
                 <a:latin typeface="Calibri"/>
               </a:rPr>
-              <a:t>WHO-5 Well-Being Index (n=38)</a:t>
+              <a:t>WHO-5 Well-Being Index (n=37)</a:t>
             </a:r>
             <a:endParaRPr b="0" lang="en-US" sz="2000" spc="-1" strike="noStrike">
               <a:solidFill>
@@ -7119,7 +7119,7 @@
                 </a:solidFill>
                 <a:latin typeface="Calibri"/>
               </a:rPr>
-              <a:t>Scores: 28%–84%, median 60%, mean 57.9%</a:t>
+              <a:t>Scores: 28%–84%, median 60%, mean 57.4%</a:t>
             </a:r>
             <a:endParaRPr b="0" lang="en-US" sz="1600" spc="-1" strike="noStrike">
               <a:solidFill>
@@ -7153,7 +7153,7 @@
                 </a:solidFill>
                 <a:latin typeface="Calibri"/>
               </a:rPr>
-              <a:t>26.3% below 50% depression-risk threshold</a:t>
+              <a:t>27.0% below 50% depression-risk threshold</a:t>
             </a:r>
             <a:endParaRPr b="0" lang="en-US" sz="1600" spc="-1" strike="noStrike">
               <a:solidFill>
@@ -7240,7 +7240,7 @@
                 </a:solidFill>
                 <a:latin typeface="Calibri"/>
               </a:rPr>
-              <a:t>BFI-10 Personality (n=48, scale 0–4)</a:t>
+              <a:t>BFI-10 Personality (n=42, scale 0–4)</a:t>
             </a:r>
             <a:endParaRPr b="0" lang="en-US" sz="2000" spc="-1" strike="noStrike">
               <a:solidFill>
@@ -7328,7 +7328,7 @@
                 </a:solidFill>
                 <a:latin typeface="Calibri"/>
               </a:rPr>
-              <a:t>Conscientiousness highest (2.84) — typical for academics (ref 2.5-2.8)</a:t>
+              <a:t>Conscientiousness highest (2.74) — typical for academics (ref 2.5-2.8)</a:t>
             </a:r>
             <a:endParaRPr b="0" lang="en-US" sz="1400" spc="-1" strike="noStrike">
               <a:solidFill>
@@ -7362,7 +7362,7 @@
                 </a:solidFill>
                 <a:latin typeface="Calibri"/>
               </a:rPr>
-              <a:t>Neuroticism lowest (1.81) but widest spread (ref 2.0-2.5)</a:t>
+              <a:t>Neuroticism lowest (1.92) but widest spread (ref 2.0-2.5)</a:t>
             </a:r>
             <a:endParaRPr b="0" lang="en-US" sz="1400" spc="-1" strike="noStrike">
               <a:solidFill>
@@ -7398,7 +7398,7 @@
                 <a:latin typeface="Calibri"/>
                 <a:ea typeface="Noto Sans CJK SC"/>
               </a:rPr>
-              <a:t>Moderate extraversion (2.10) (ref 2.3 – 2.7)</a:t>
+              <a:t>Moderate extraversion (2.07) (ref 2.3 – 2.7)</a:t>
             </a:r>
             <a:endParaRPr b="0" lang="en-US" sz="1400" spc="-1" strike="noStrike">
               <a:solidFill>
@@ -7432,7 +7432,7 @@
                 </a:solidFill>
                 <a:latin typeface="Calibri"/>
               </a:rPr>
-              <a:t>Agreeableness (2.65) (ref 2.5-2.8)</a:t>
+              <a:t>Agreeableness (2.68) (ref 2.5-2.8)</a:t>
             </a:r>
             <a:endParaRPr b="0" lang="en-US" sz="1400" spc="-1" strike="noStrike">
               <a:solidFill>
@@ -7466,7 +7466,7 @@
                 </a:solidFill>
                 <a:latin typeface="Calibri"/>
               </a:rPr>
-              <a:t>Openness (2.32) (ref 2.5-3.0)</a:t>
+              <a:t>Openness (2.42) (ref 2.5-3.0)</a:t>
             </a:r>
             <a:endParaRPr b="0" lang="en-US" sz="1400" spc="-1" strike="noStrike">
               <a:solidFill>
@@ -7721,7 +7721,7 @@
                 </a:solidFill>
                 <a:latin typeface="Calibri"/>
               </a:rPr>
-              <a:t>Stress (81 responses, 36 participants)</a:t>
+              <a:t>Stress (70 responses, 36 participants)</a:t>
             </a:r>
             <a:endParaRPr b="0" lang="en-US" sz="2000" spc="-1" strike="noStrike">
               <a:solidFill>
@@ -7839,7 +7839,7 @@
                 </a:solidFill>
                 <a:latin typeface="Calibri"/>
               </a:rPr>
-              <a:t>Sleep (73 responses)</a:t>
+              <a:t>Sleep (64 responses)</a:t>
             </a:r>
             <a:endParaRPr b="0" lang="en-US" sz="2000" spc="-1" strike="noStrike">
               <a:solidFill>
@@ -7904,7 +7904,7 @@
                 </a:solidFill>
                 <a:latin typeface="Calibri"/>
               </a:rPr>
-              <a:t>53.4% reported "Good" quality, but ...</a:t>
+              <a:t>51.6% reported "Good" quality, but ...</a:t>
             </a:r>
             <a:endParaRPr b="0" lang="en-US" sz="1600" spc="-1" strike="noStrike">
               <a:solidFill>
@@ -7972,7 +7972,7 @@
                 </a:solidFill>
                 <a:latin typeface="Calibri"/>
               </a:rPr>
-              <a:t>Only 6.8% got more than 8 hours</a:t>
+              <a:t>Only 4.7% got more than 8 hours</a:t>
             </a:r>
             <a:endParaRPr b="0" lang="en-US" sz="1600" spc="-1" strike="noStrike">
               <a:solidFill>
@@ -8299,7 +8299,7 @@
                 </a:solidFill>
                 <a:latin typeface="Calibri"/>
               </a:rPr>
-              <a:t>Screen events kept 99.1%, step count 87.9%, activity 83.5%</a:t>
+              <a:t>Screen events kept 99.1%, step count 87.9%, activity 83.3%</a:t>
             </a:r>
             <a:endParaRPr b="0" lang="en-US" sz="1800" spc="-1" strike="noStrike">
               <a:solidFill>
@@ -8333,7 +8333,7 @@
                 </a:solidFill>
                 <a:latin typeface="Calibri"/>
               </a:rPr>
-              <a:t>Location 70.6%, ambient light 64.2%, heartbeat 52.7%</a:t>
+              <a:t>Location 70.0%, ambient light 64.0%, heartbeat 51.9%</a:t>
             </a:r>
             <a:endParaRPr b="0" lang="en-US" sz="1800" spc="-1" strike="noStrike">
               <a:solidFill>
@@ -8944,7 +8944,7 @@
                 </a:solidFill>
                 <a:latin typeface="Calibri"/>
               </a:rPr>
-              <a:t>~22 MB across 15 Parquet files</a:t>
+              <a:t>~22 MB across 17 Parquet files</a:t>
             </a:r>
             <a:endParaRPr b="0" lang="en-US" sz="2000" spc="-1" strike="noStrike">
               <a:solidFill>
@@ -9277,7 +9277,7 @@
                           </a:solidFill>
                           <a:latin typeface="Calibri"/>
                         </a:rPr>
-                        <a:t>393,319</a:t>
+                        <a:t>393,300</a:t>
                       </a:r>
                       <a:endParaRPr b="0" lang="en-US" sz="1100" spc="-1" strike="noStrike">
                         <a:solidFill>
@@ -9447,7 +9447,7 @@
                           </a:solidFill>
                           <a:latin typeface="Calibri"/>
                         </a:rPr>
-                        <a:t>166,530</a:t>
+                        <a:t>166,047</a:t>
                       </a:r>
                       <a:endParaRPr b="0" lang="en-US" sz="1100" spc="-1" strike="noStrike">
                         <a:solidFill>
@@ -9623,7 +9623,7 @@
                           </a:solidFill>
                           <a:latin typeface="Calibri"/>
                         </a:rPr>
-                        <a:t>93,913</a:t>
+                        <a:t>93,209</a:t>
                       </a:r>
                       <a:endParaRPr b="0" lang="en-US" sz="1100" spc="-1" strike="noStrike">
                         <a:solidFill>
@@ -9799,7 +9799,7 @@
                           </a:solidFill>
                           <a:latin typeface="Calibri"/>
                         </a:rPr>
-                        <a:t>107,994</a:t>
+                        <a:t>106,244</a:t>
                       </a:r>
                       <a:endParaRPr b="0" lang="en-US" sz="1100" spc="-1" strike="noStrike">
                         <a:solidFill>
@@ -9975,7 +9975,7 @@
                           </a:solidFill>
                           <a:latin typeface="Calibri"/>
                         </a:rPr>
-                        <a:t>3,074</a:t>
+                        <a:t>3,050</a:t>
                       </a:r>
                       <a:endParaRPr b="0" lang="en-US" sz="1100" spc="-1" strike="noStrike">
                         <a:solidFill>
@@ -10142,7 +10142,7 @@
                           </a:solidFill>
                           <a:latin typeface="Arial"/>
                         </a:rPr>
-                        <a:t>3057</a:t>
+                        <a:t>3,033</a:t>
                       </a:r>
                       <a:endParaRPr b="0" lang="en-US" sz="1100" spc="-1" strike="noStrike">
                         <a:solidFill>
@@ -10305,7 +10305,7 @@
                           </a:solidFill>
                           <a:latin typeface="Arial"/>
                         </a:rPr>
-                        <a:t>13284</a:t>
+                        <a:t>13,263</a:t>
                       </a:r>
                       <a:endParaRPr b="0" lang="en-US" sz="1100" spc="-1" strike="noStrike">
                         <a:solidFill>
@@ -10631,7 +10631,7 @@
                           </a:solidFill>
                           <a:latin typeface="Arial"/>
                         </a:rPr>
-                        <a:t>1999</a:t>
+                        <a:t>1,993</a:t>
                       </a:r>
                       <a:endParaRPr b="0" lang="en-US" sz="1100" spc="-1" strike="noStrike">
                         <a:solidFill>
@@ -11217,7 +11217,7 @@
                           </a:solidFill>
                           <a:latin typeface="Calibri"/>
                         </a:rPr>
-                        <a:t>81</a:t>
+                        <a:t>70</a:t>
                       </a:r>
                       <a:endParaRPr b="0" lang="en-US" sz="1100" spc="-1" strike="noStrike">
                         <a:solidFill>
@@ -11393,7 +11393,7 @@
                           </a:solidFill>
                           <a:latin typeface="Calibri"/>
                         </a:rPr>
-                        <a:t>73</a:t>
+                        <a:t>64</a:t>
                       </a:r>
                       <a:endParaRPr b="0" lang="en-US" sz="1100" spc="-1" strike="noStrike">
                         <a:solidFill>
@@ -11921,7 +11921,7 @@
                           </a:solidFill>
                           <a:latin typeface="Calibri"/>
                         </a:rPr>
-                        <a:t>224</a:t>
+                        <a:t>205</a:t>
                       </a:r>
                       <a:endParaRPr b="0" lang="en-US" sz="1100" spc="-1" strike="noStrike">
                         <a:solidFill>
@@ -12404,7 +12404,7 @@
                 </a:solidFill>
                 <a:latin typeface="Calibri"/>
               </a:rPr>
-              <a:t>Mean coverage of 34.7% during the conference indicates frequent device disconnections. Affects reliability of keep-alive signals as a proxy for app uptime.</a:t>
+              <a:t>Mean coverage of 33.4% during the conference indicates frequent device disconnections. Affects reliability of keep-alive signals as a proxy for app uptime.</a:t>
             </a:r>
             <a:endParaRPr b="0" lang="en-US" sz="1700" spc="-1" strike="noStrike">
               <a:solidFill>
@@ -15862,7 +15862,7 @@
                 </a:solidFill>
                 <a:latin typeface="Calibri"/>
               </a:rPr>
-              <a:t>Mean heartbeat coverage during conference: 34.7%</a:t>
+              <a:t>Mean heartbeat coverage during conference: 33.4%</a:t>
             </a:r>
             <a:endParaRPr b="0" lang="en-US" sz="1400" spc="-1" strike="noStrike">
               <a:solidFill>
@@ -15919,8 +15919,8 @@
         </p:blipFill>
         <p:spPr>
           <a:xfrm>
-            <a:off x="731520" y="1143000"/>
-            <a:ext cx="6583680" cy="5094000"/>
+            <a:off x="731520" y="1601824"/>
+            <a:ext cx="6583680" cy="4176351"/>
           </a:xfrm>
           <a:prstGeom prst="rect">
             <a:avLst/>
@@ -16873,7 +16873,7 @@
                           </a:solidFill>
                           <a:latin typeface="Calibri"/>
                         </a:rPr>
-                        <a:t>81</a:t>
+                        <a:t>70</a:t>
                       </a:r>
                       <a:endParaRPr b="0" lang="en-US" sz="1500" spc="-1" strike="noStrike">
                         <a:solidFill>
@@ -17046,7 +17046,7 @@
                           </a:solidFill>
                           <a:latin typeface="Calibri"/>
                         </a:rPr>
-                        <a:t>73</a:t>
+                        <a:t>64</a:t>
                       </a:r>
                       <a:endParaRPr b="0" lang="en-US" sz="1500" spc="-1" strike="noStrike">
                         <a:solidFill>
@@ -17219,7 +17219,7 @@
                           </a:solidFill>
                           <a:latin typeface="Calibri"/>
                         </a:rPr>
-                        <a:t>57</a:t>
+                        <a:t>39</a:t>
                       </a:r>
                       <a:endParaRPr b="0" lang="en-US" sz="1500" spc="-1" strike="noStrike">
                         <a:solidFill>
@@ -17392,7 +17392,7 @@
                           </a:solidFill>
                           <a:latin typeface="Calibri"/>
                         </a:rPr>
-                        <a:t>48</a:t>
+                        <a:t>44</a:t>
                       </a:r>
                       <a:endParaRPr b="0" lang="en-US" sz="1500" spc="-1" strike="noStrike">
                         <a:solidFill>
@@ -17565,7 +17565,7 @@
                           </a:solidFill>
                           <a:latin typeface="Calibri"/>
                         </a:rPr>
-                        <a:t>38</a:t>
+                        <a:t>37</a:t>
                       </a:r>
                       <a:endParaRPr b="0" lang="en-US" sz="1500" spc="-1" strike="noStrike">
                         <a:solidFill>
@@ -17738,7 +17738,7 @@
                           </a:solidFill>
                           <a:latin typeface="Calibri"/>
                         </a:rPr>
-                        <a:t>145</a:t>
+                        <a:t>129</a:t>
                       </a:r>
                       <a:endParaRPr b="0" lang="en-US" sz="1500" spc="-1" strike="noStrike">
                         <a:solidFill>
@@ -17911,7 +17911,7 @@
                           </a:solidFill>
                           <a:latin typeface="Calibri"/>
                         </a:rPr>
-                        <a:t>79</a:t>
+                        <a:t>76</a:t>
                       </a:r>
                       <a:endParaRPr b="0" lang="en-US" sz="1500" spc="-1" strike="noStrike">
                         <a:solidFill>

</xml_diff>